<commit_message>
Update Projeto Final IA FIT - Análise e Projeção de Emissão de CO₂ no Brasil.pptx
</commit_message>
<xml_diff>
--- a/Projeto Final IA FIT - Análise e Projeção de Emissão de CO₂ no Brasil.pptx
+++ b/Projeto Final IA FIT - Análise e Projeção de Emissão de CO₂ no Brasil.pptx
@@ -31,8 +31,8 @@
     <p:sldId id="274" r:id="rId22"/>
     <p:sldId id="275" r:id="rId23"/>
     <p:sldId id="279" r:id="rId24"/>
-    <p:sldId id="280" r:id="rId25"/>
-    <p:sldId id="283" r:id="rId26"/>
+    <p:sldId id="283" r:id="rId25"/>
+    <p:sldId id="280" r:id="rId26"/>
     <p:sldId id="281" r:id="rId27"/>
     <p:sldId id="282" r:id="rId28"/>
     <p:sldId id="276" r:id="rId29"/>
@@ -2393,7 +2393,7 @@
           </a:lstStyle>
           <a:p>
             <a:fld id="{7AA294C4-FE9B-4721-BD6B-C9CEACDB10A1}" type="datetimeFigureOut">
-              <a:t>07/06/2026</a:t>
+              <a:t>08/06/2026</a:t>
             </a:fld>
             <a:endParaRPr lang="pt-BR"/>
           </a:p>
@@ -4035,7 +4035,7 @@
         <p:cNvPr id="1" name="">
           <a:extLst>
             <a:ext uri="{FF2B5EF4-FFF2-40B4-BE49-F238E27FC236}">
-              <a16:creationId xmlns:a16="http://schemas.microsoft.com/office/drawing/2014/main" id="{43049FAC-8D62-7267-283A-11127A87CA41}"/>
+              <a16:creationId xmlns:a16="http://schemas.microsoft.com/office/drawing/2014/main" id="{E406086C-8112-B194-060B-733149756828}"/>
             </a:ext>
           </a:extLst>
         </p:cNvPr>
@@ -4055,7 +4055,7 @@
           <p:cNvPr id="2" name="Slide Image Placeholder 1">
             <a:extLst>
               <a:ext uri="{FF2B5EF4-FFF2-40B4-BE49-F238E27FC236}">
-                <a16:creationId xmlns:a16="http://schemas.microsoft.com/office/drawing/2014/main" id="{ABC38D5D-59E9-E976-DE5D-8E1153CB8EF4}"/>
+                <a16:creationId xmlns:a16="http://schemas.microsoft.com/office/drawing/2014/main" id="{6D63389D-5632-CAC0-65EA-C44C0E8B6FED}"/>
               </a:ext>
             </a:extLst>
           </p:cNvPr>
@@ -4073,7 +4073,7 @@
           <p:cNvPr id="3" name="Notes Placeholder 2">
             <a:extLst>
               <a:ext uri="{FF2B5EF4-FFF2-40B4-BE49-F238E27FC236}">
-                <a16:creationId xmlns:a16="http://schemas.microsoft.com/office/drawing/2014/main" id="{E6CBC9E0-98CC-292B-BC7B-35F33A707376}"/>
+                <a16:creationId xmlns:a16="http://schemas.microsoft.com/office/drawing/2014/main" id="{4DA06F54-7BE6-BC2D-0E98-F6066FC25632}"/>
               </a:ext>
             </a:extLst>
           </p:cNvPr>
@@ -4098,7 +4098,7 @@
           <p:cNvPr id="4" name="Slide Number Placeholder 3">
             <a:extLst>
               <a:ext uri="{FF2B5EF4-FFF2-40B4-BE49-F238E27FC236}">
-                <a16:creationId xmlns:a16="http://schemas.microsoft.com/office/drawing/2014/main" id="{6D15A21F-FE88-FBFD-FF52-36A683D6268A}"/>
+                <a16:creationId xmlns:a16="http://schemas.microsoft.com/office/drawing/2014/main" id="{1B4D9617-F1F9-22ED-A06C-A9D424E3D55D}"/>
               </a:ext>
             </a:extLst>
           </p:cNvPr>
@@ -4125,7 +4125,7 @@
     </p:spTree>
     <p:extLst>
       <p:ext uri="{BB962C8B-B14F-4D97-AF65-F5344CB8AC3E}">
-        <p14:creationId xmlns:p14="http://schemas.microsoft.com/office/powerpoint/2010/main" val="1159269657"/>
+        <p14:creationId xmlns:p14="http://schemas.microsoft.com/office/powerpoint/2010/main" val="530756379"/>
       </p:ext>
     </p:extLst>
   </p:cSld>
@@ -4143,7 +4143,7 @@
         <p:cNvPr id="1" name="">
           <a:extLst>
             <a:ext uri="{FF2B5EF4-FFF2-40B4-BE49-F238E27FC236}">
-              <a16:creationId xmlns:a16="http://schemas.microsoft.com/office/drawing/2014/main" id="{E406086C-8112-B194-060B-733149756828}"/>
+              <a16:creationId xmlns:a16="http://schemas.microsoft.com/office/drawing/2014/main" id="{43049FAC-8D62-7267-283A-11127A87CA41}"/>
             </a:ext>
           </a:extLst>
         </p:cNvPr>
@@ -4163,7 +4163,7 @@
           <p:cNvPr id="2" name="Slide Image Placeholder 1">
             <a:extLst>
               <a:ext uri="{FF2B5EF4-FFF2-40B4-BE49-F238E27FC236}">
-                <a16:creationId xmlns:a16="http://schemas.microsoft.com/office/drawing/2014/main" id="{6D63389D-5632-CAC0-65EA-C44C0E8B6FED}"/>
+                <a16:creationId xmlns:a16="http://schemas.microsoft.com/office/drawing/2014/main" id="{ABC38D5D-59E9-E976-DE5D-8E1153CB8EF4}"/>
               </a:ext>
             </a:extLst>
           </p:cNvPr>
@@ -4181,7 +4181,7 @@
           <p:cNvPr id="3" name="Notes Placeholder 2">
             <a:extLst>
               <a:ext uri="{FF2B5EF4-FFF2-40B4-BE49-F238E27FC236}">
-                <a16:creationId xmlns:a16="http://schemas.microsoft.com/office/drawing/2014/main" id="{4DA06F54-7BE6-BC2D-0E98-F6066FC25632}"/>
+                <a16:creationId xmlns:a16="http://schemas.microsoft.com/office/drawing/2014/main" id="{E6CBC9E0-98CC-292B-BC7B-35F33A707376}"/>
               </a:ext>
             </a:extLst>
           </p:cNvPr>
@@ -4206,7 +4206,7 @@
           <p:cNvPr id="4" name="Slide Number Placeholder 3">
             <a:extLst>
               <a:ext uri="{FF2B5EF4-FFF2-40B4-BE49-F238E27FC236}">
-                <a16:creationId xmlns:a16="http://schemas.microsoft.com/office/drawing/2014/main" id="{1B4D9617-F1F9-22ED-A06C-A9D424E3D55D}"/>
+                <a16:creationId xmlns:a16="http://schemas.microsoft.com/office/drawing/2014/main" id="{6D15A21F-FE88-FBFD-FF52-36A683D6268A}"/>
               </a:ext>
             </a:extLst>
           </p:cNvPr>
@@ -4233,7 +4233,7 @@
     </p:spTree>
     <p:extLst>
       <p:ext uri="{BB962C8B-B14F-4D97-AF65-F5344CB8AC3E}">
-        <p14:creationId xmlns:p14="http://schemas.microsoft.com/office/powerpoint/2010/main" val="530756379"/>
+        <p14:creationId xmlns:p14="http://schemas.microsoft.com/office/powerpoint/2010/main" val="1159269657"/>
       </p:ext>
     </p:extLst>
   </p:cSld>
@@ -6414,6 +6414,18 @@
   <p:clrMapOvr>
     <a:masterClrMapping/>
   </p:clrMapOvr>
+  <mc:AlternateContent xmlns:mc="http://schemas.openxmlformats.org/markup-compatibility/2006">
+    <mc:Choice xmlns:p159="http://schemas.microsoft.com/office/powerpoint/2015/09/main" Requires="p159">
+      <p:transition xmlns:p14="http://schemas.microsoft.com/office/powerpoint/2010/main" spd="slow" p14:dur="2000">
+        <p159:morph option="byObject"/>
+      </p:transition>
+    </mc:Choice>
+    <mc:Fallback>
+      <p:transition spd="slow">
+        <p:fade/>
+      </p:transition>
+    </mc:Fallback>
+  </mc:AlternateContent>
 </p:sld>
 </file>
 
@@ -8013,6 +8025,18 @@
   <p:clrMapOvr>
     <a:masterClrMapping/>
   </p:clrMapOvr>
+  <mc:AlternateContent xmlns:mc="http://schemas.openxmlformats.org/markup-compatibility/2006">
+    <mc:Choice xmlns:p159="http://schemas.microsoft.com/office/powerpoint/2015/09/main" Requires="p159">
+      <p:transition xmlns:p14="http://schemas.microsoft.com/office/powerpoint/2010/main" spd="slow" p14:dur="2000">
+        <p159:morph option="byObject"/>
+      </p:transition>
+    </mc:Choice>
+    <mc:Fallback>
+      <p:transition spd="slow">
+        <p:fade/>
+      </p:transition>
+    </mc:Fallback>
+  </mc:AlternateContent>
 </p:sld>
 </file>
 
@@ -8584,6 +8608,18 @@
   <p:clrMapOvr>
     <a:masterClrMapping/>
   </p:clrMapOvr>
+  <mc:AlternateContent xmlns:mc="http://schemas.openxmlformats.org/markup-compatibility/2006">
+    <mc:Choice xmlns:p159="http://schemas.microsoft.com/office/powerpoint/2015/09/main" Requires="p159">
+      <p:transition xmlns:p14="http://schemas.microsoft.com/office/powerpoint/2010/main" spd="slow" p14:dur="2000">
+        <p159:morph option="byObject"/>
+      </p:transition>
+    </mc:Choice>
+    <mc:Fallback>
+      <p:transition spd="slow">
+        <p:fade/>
+      </p:transition>
+    </mc:Fallback>
+  </mc:AlternateContent>
 </p:sld>
 </file>
 
@@ -10031,6 +10067,18 @@
   <p:clrMapOvr>
     <a:masterClrMapping/>
   </p:clrMapOvr>
+  <mc:AlternateContent xmlns:mc="http://schemas.openxmlformats.org/markup-compatibility/2006">
+    <mc:Choice xmlns:p159="http://schemas.microsoft.com/office/powerpoint/2015/09/main" Requires="p159">
+      <p:transition xmlns:p14="http://schemas.microsoft.com/office/powerpoint/2010/main" spd="slow" p14:dur="2000">
+        <p159:morph option="byObject"/>
+      </p:transition>
+    </mc:Choice>
+    <mc:Fallback>
+      <p:transition spd="slow">
+        <p:fade/>
+      </p:transition>
+    </mc:Fallback>
+  </mc:AlternateContent>
 </p:sld>
 </file>
 
@@ -11306,6 +11354,18 @@
   <p:clrMapOvr>
     <a:masterClrMapping/>
   </p:clrMapOvr>
+  <mc:AlternateContent xmlns:mc="http://schemas.openxmlformats.org/markup-compatibility/2006">
+    <mc:Choice xmlns:p159="http://schemas.microsoft.com/office/powerpoint/2015/09/main" Requires="p159">
+      <p:transition xmlns:p14="http://schemas.microsoft.com/office/powerpoint/2010/main" spd="slow" p14:dur="2000">
+        <p159:morph option="byObject"/>
+      </p:transition>
+    </mc:Choice>
+    <mc:Fallback>
+      <p:transition spd="slow">
+        <p:fade/>
+      </p:transition>
+    </mc:Fallback>
+  </mc:AlternateContent>
 </p:sld>
 </file>
 
@@ -12590,6 +12650,18 @@
   <p:clrMapOvr>
     <a:masterClrMapping/>
   </p:clrMapOvr>
+  <mc:AlternateContent xmlns:mc="http://schemas.openxmlformats.org/markup-compatibility/2006">
+    <mc:Choice xmlns:p159="http://schemas.microsoft.com/office/powerpoint/2015/09/main" Requires="p159">
+      <p:transition xmlns:p14="http://schemas.microsoft.com/office/powerpoint/2010/main" spd="slow" p14:dur="2000">
+        <p159:morph option="byObject"/>
+      </p:transition>
+    </mc:Choice>
+    <mc:Fallback>
+      <p:transition spd="slow">
+        <p:fade/>
+      </p:transition>
+    </mc:Fallback>
+  </mc:AlternateContent>
 </p:sld>
 </file>
 
@@ -12846,6 +12918,18 @@
   <p:clrMapOvr>
     <a:masterClrMapping/>
   </p:clrMapOvr>
+  <mc:AlternateContent xmlns:mc="http://schemas.openxmlformats.org/markup-compatibility/2006">
+    <mc:Choice xmlns:p159="http://schemas.microsoft.com/office/powerpoint/2015/09/main" Requires="p159">
+      <p:transition xmlns:p14="http://schemas.microsoft.com/office/powerpoint/2010/main" spd="slow" p14:dur="2000">
+        <p159:morph option="byObject"/>
+      </p:transition>
+    </mc:Choice>
+    <mc:Fallback>
+      <p:transition spd="slow">
+        <p:fade/>
+      </p:transition>
+    </mc:Fallback>
+  </mc:AlternateContent>
 </p:sld>
 </file>
 
@@ -15605,6 +15689,18 @@
   <p:clrMapOvr>
     <a:masterClrMapping/>
   </p:clrMapOvr>
+  <mc:AlternateContent xmlns:mc="http://schemas.openxmlformats.org/markup-compatibility/2006">
+    <mc:Choice xmlns:p159="http://schemas.microsoft.com/office/powerpoint/2015/09/main" Requires="p159">
+      <p:transition xmlns:p14="http://schemas.microsoft.com/office/powerpoint/2010/main" spd="slow" p14:dur="2000">
+        <p159:morph option="byObject"/>
+      </p:transition>
+    </mc:Choice>
+    <mc:Fallback>
+      <p:transition spd="slow">
+        <p:fade/>
+      </p:transition>
+    </mc:Fallback>
+  </mc:AlternateContent>
 </p:sld>
 </file>
 
@@ -16688,6 +16784,18 @@
   <p:clrMapOvr>
     <a:masterClrMapping/>
   </p:clrMapOvr>
+  <mc:AlternateContent xmlns:mc="http://schemas.openxmlformats.org/markup-compatibility/2006">
+    <mc:Choice xmlns:p159="http://schemas.microsoft.com/office/powerpoint/2015/09/main" Requires="p159">
+      <p:transition xmlns:p14="http://schemas.microsoft.com/office/powerpoint/2010/main" spd="slow" p14:dur="2000">
+        <p159:morph option="byObject"/>
+      </p:transition>
+    </mc:Choice>
+    <mc:Fallback>
+      <p:transition spd="slow">
+        <p:fade/>
+      </p:transition>
+    </mc:Fallback>
+  </mc:AlternateContent>
 </p:sld>
 </file>
 
@@ -17375,6 +17483,18 @@
   <p:clrMapOvr>
     <a:masterClrMapping/>
   </p:clrMapOvr>
+  <mc:AlternateContent xmlns:mc="http://schemas.openxmlformats.org/markup-compatibility/2006">
+    <mc:Choice xmlns:p159="http://schemas.microsoft.com/office/powerpoint/2015/09/main" Requires="p159">
+      <p:transition xmlns:p14="http://schemas.microsoft.com/office/powerpoint/2010/main" spd="slow" p14:dur="2000">
+        <p159:morph option="byObject"/>
+      </p:transition>
+    </mc:Choice>
+    <mc:Fallback>
+      <p:transition spd="slow">
+        <p:fade/>
+      </p:transition>
+    </mc:Fallback>
+  </mc:AlternateContent>
 </p:sld>
 </file>
 
@@ -18315,6 +18435,18 @@
   <p:clrMapOvr>
     <a:masterClrMapping/>
   </p:clrMapOvr>
+  <mc:AlternateContent xmlns:mc="http://schemas.openxmlformats.org/markup-compatibility/2006">
+    <mc:Choice xmlns:p159="http://schemas.microsoft.com/office/powerpoint/2015/09/main" Requires="p159">
+      <p:transition xmlns:p14="http://schemas.microsoft.com/office/powerpoint/2010/main" spd="slow" p14:dur="2000">
+        <p159:morph option="byObject"/>
+      </p:transition>
+    </mc:Choice>
+    <mc:Fallback>
+      <p:transition spd="slow">
+        <p:fade/>
+      </p:transition>
+    </mc:Fallback>
+  </mc:AlternateContent>
 </p:sld>
 </file>
 
@@ -19030,6 +19162,18 @@
   <p:clrMapOvr>
     <a:masterClrMapping/>
   </p:clrMapOvr>
+  <mc:AlternateContent xmlns:mc="http://schemas.openxmlformats.org/markup-compatibility/2006">
+    <mc:Choice xmlns:p159="http://schemas.microsoft.com/office/powerpoint/2015/09/main" Requires="p159">
+      <p:transition xmlns:p14="http://schemas.microsoft.com/office/powerpoint/2010/main" spd="slow" p14:dur="2000">
+        <p159:morph option="byObject"/>
+      </p:transition>
+    </mc:Choice>
+    <mc:Fallback>
+      <p:transition spd="slow">
+        <p:fade/>
+      </p:transition>
+    </mc:Fallback>
+  </mc:AlternateContent>
 </p:sld>
 </file>
 
@@ -20307,6 +20451,18 @@
   <p:clrMapOvr>
     <a:masterClrMapping/>
   </p:clrMapOvr>
+  <mc:AlternateContent xmlns:mc="http://schemas.openxmlformats.org/markup-compatibility/2006">
+    <mc:Choice xmlns:p159="http://schemas.microsoft.com/office/powerpoint/2015/09/main" Requires="p159">
+      <p:transition xmlns:p14="http://schemas.microsoft.com/office/powerpoint/2010/main" spd="slow" p14:dur="2000">
+        <p159:morph option="byObject"/>
+      </p:transition>
+    </mc:Choice>
+    <mc:Fallback>
+      <p:transition spd="slow">
+        <p:fade/>
+      </p:transition>
+    </mc:Fallback>
+  </mc:AlternateContent>
 </p:sld>
 </file>
 
@@ -21036,6 +21192,18 @@
   <p:clrMapOvr>
     <a:masterClrMapping/>
   </p:clrMapOvr>
+  <mc:AlternateContent xmlns:mc="http://schemas.openxmlformats.org/markup-compatibility/2006">
+    <mc:Choice xmlns:p159="http://schemas.microsoft.com/office/powerpoint/2015/09/main" Requires="p159">
+      <p:transition xmlns:p14="http://schemas.microsoft.com/office/powerpoint/2010/main" spd="slow" p14:dur="2000">
+        <p159:morph option="byObject"/>
+      </p:transition>
+    </mc:Choice>
+    <mc:Fallback>
+      <p:transition spd="slow">
+        <p:fade/>
+      </p:transition>
+    </mc:Fallback>
+  </mc:AlternateContent>
 </p:sld>
 </file>
 
@@ -22028,6 +22196,18 @@
   <p:clrMapOvr>
     <a:masterClrMapping/>
   </p:clrMapOvr>
+  <mc:AlternateContent xmlns:mc="http://schemas.openxmlformats.org/markup-compatibility/2006">
+    <mc:Choice xmlns:p159="http://schemas.microsoft.com/office/powerpoint/2015/09/main" Requires="p159">
+      <p:transition xmlns:p14="http://schemas.microsoft.com/office/powerpoint/2010/main" spd="slow" p14:dur="2000">
+        <p159:morph option="byObject"/>
+      </p:transition>
+    </mc:Choice>
+    <mc:Fallback>
+      <p:transition spd="slow">
+        <p:fade/>
+      </p:transition>
+    </mc:Fallback>
+  </mc:AlternateContent>
 </p:sld>
 </file>
 
@@ -22235,10 +22415,285 @@
   <p:clrMapOvr>
     <a:masterClrMapping/>
   </p:clrMapOvr>
+  <mc:AlternateContent xmlns:mc="http://schemas.openxmlformats.org/markup-compatibility/2006">
+    <mc:Choice xmlns:p159="http://schemas.microsoft.com/office/powerpoint/2015/09/main" Requires="p159">
+      <p:transition xmlns:p14="http://schemas.microsoft.com/office/powerpoint/2010/main" spd="slow" p14:dur="2000">
+        <p159:morph option="byObject"/>
+      </p:transition>
+    </mc:Choice>
+    <mc:Fallback>
+      <p:transition spd="slow">
+        <p:fade/>
+      </p:transition>
+    </mc:Fallback>
+  </mc:AlternateContent>
 </p:sld>
 </file>
 
 <file path=ppt/slides/slide24.xml><?xml version="1.0" encoding="utf-8"?>
+<p:sld xmlns:a="http://schemas.openxmlformats.org/drawingml/2006/main" xmlns:r="http://schemas.openxmlformats.org/officeDocument/2006/relationships" xmlns:p="http://schemas.openxmlformats.org/presentationml/2006/main">
+  <p:cSld>
+    <p:spTree>
+      <p:nvGrpSpPr>
+        <p:cNvPr id="1" name="">
+          <a:extLst>
+            <a:ext uri="{FF2B5EF4-FFF2-40B4-BE49-F238E27FC236}">
+              <a16:creationId xmlns:a16="http://schemas.microsoft.com/office/drawing/2014/main" id="{224FF6E5-DD65-A9C9-6345-97B189D901D3}"/>
+            </a:ext>
+          </a:extLst>
+        </p:cNvPr>
+        <p:cNvGrpSpPr/>
+        <p:nvPr/>
+      </p:nvGrpSpPr>
+      <p:grpSpPr>
+        <a:xfrm>
+          <a:off x="0" y="0"/>
+          <a:ext cx="0" cy="0"/>
+          <a:chOff x="0" y="0"/>
+          <a:chExt cx="0" cy="0"/>
+        </a:xfrm>
+      </p:grpSpPr>
+      <p:sp>
+        <p:nvSpPr>
+          <p:cNvPr id="2" name="Shape 0">
+            <a:extLst>
+              <a:ext uri="{FF2B5EF4-FFF2-40B4-BE49-F238E27FC236}">
+                <a16:creationId xmlns:a16="http://schemas.microsoft.com/office/drawing/2014/main" id="{A9B3D0C6-51D4-6FF5-AF37-776CD30E5568}"/>
+              </a:ext>
+            </a:extLst>
+          </p:cNvPr>
+          <p:cNvSpPr/>
+          <p:nvPr/>
+        </p:nvSpPr>
+        <p:spPr>
+          <a:xfrm>
+            <a:off x="0" y="-27432"/>
+            <a:ext cx="9144000" cy="868680"/>
+          </a:xfrm>
+          <a:prstGeom prst="rect">
+            <a:avLst/>
+          </a:prstGeom>
+          <a:solidFill>
+            <a:schemeClr val="accent2">
+              <a:lumMod val="75000"/>
+            </a:schemeClr>
+          </a:solidFill>
+          <a:ln w="12700">
+            <a:solidFill>
+              <a:srgbClr val="333333"/>
+            </a:solidFill>
+            <a:prstDash val="solid"/>
+          </a:ln>
+        </p:spPr>
+        <p:txBody>
+          <a:bodyPr/>
+          <a:lstStyle/>
+          <a:p>
+            <a:endParaRPr lang="pt-BR"/>
+          </a:p>
+        </p:txBody>
+      </p:sp>
+      <p:sp>
+        <p:nvSpPr>
+          <p:cNvPr id="3" name="Text 1">
+            <a:extLst>
+              <a:ext uri="{FF2B5EF4-FFF2-40B4-BE49-F238E27FC236}">
+                <a16:creationId xmlns:a16="http://schemas.microsoft.com/office/drawing/2014/main" id="{F4A3942D-CE89-EB04-A265-4ED2B11A16D7}"/>
+              </a:ext>
+            </a:extLst>
+          </p:cNvPr>
+          <p:cNvSpPr/>
+          <p:nvPr/>
+        </p:nvSpPr>
+        <p:spPr>
+          <a:xfrm>
+            <a:off x="411480" y="91440"/>
+            <a:ext cx="8229600" cy="685800"/>
+          </a:xfrm>
+          <a:prstGeom prst="rect">
+            <a:avLst/>
+          </a:prstGeom>
+          <a:noFill/>
+          <a:ln/>
+        </p:spPr>
+        <p:txBody>
+          <a:bodyPr wrap="square" lIns="0" tIns="0" rIns="0" bIns="0" rtlCol="0" anchor="ctr"/>
+          <a:lstStyle/>
+          <a:p>
+            <a:pPr marL="0" indent="0" algn="l">
+              <a:buNone/>
+            </a:pPr>
+            <a:r>
+              <a:rPr lang="en-US" sz="3000" b="1" dirty="0" err="1">
+                <a:solidFill>
+                  <a:srgbClr val="FFFFFF"/>
+                </a:solidFill>
+                <a:latin typeface="Arial Black" pitchFamily="34" charset="0"/>
+              </a:rPr>
+              <a:t>Distribuição</a:t>
+            </a:r>
+            <a:r>
+              <a:rPr lang="en-US" sz="3000" b="1" dirty="0">
+                <a:solidFill>
+                  <a:srgbClr val="FFFFFF"/>
+                </a:solidFill>
+                <a:latin typeface="Arial Black" pitchFamily="34" charset="0"/>
+              </a:rPr>
+              <a:t> de </a:t>
+            </a:r>
+            <a:r>
+              <a:rPr lang="en-US" sz="3000" b="1" dirty="0" err="1">
+                <a:solidFill>
+                  <a:srgbClr val="FFFFFF"/>
+                </a:solidFill>
+                <a:latin typeface="Arial Black" pitchFamily="34" charset="0"/>
+              </a:rPr>
+              <a:t>Emissões</a:t>
+            </a:r>
+            <a:r>
+              <a:rPr lang="en-US" sz="3000" b="1" dirty="0">
+                <a:solidFill>
+                  <a:srgbClr val="FFFFFF"/>
+                </a:solidFill>
+                <a:latin typeface="Arial Black" pitchFamily="34" charset="0"/>
+              </a:rPr>
+              <a:t> (N1)</a:t>
+            </a:r>
+            <a:endParaRPr lang="en-US" sz="3000" dirty="0"/>
+          </a:p>
+        </p:txBody>
+      </p:sp>
+      <p:sp>
+        <p:nvSpPr>
+          <p:cNvPr id="24" name="Text 22">
+            <a:extLst>
+              <a:ext uri="{FF2B5EF4-FFF2-40B4-BE49-F238E27FC236}">
+                <a16:creationId xmlns:a16="http://schemas.microsoft.com/office/drawing/2014/main" id="{7562FC1E-FF62-8B6E-0480-C50B44C1BA69}"/>
+              </a:ext>
+            </a:extLst>
+          </p:cNvPr>
+          <p:cNvSpPr/>
+          <p:nvPr/>
+        </p:nvSpPr>
+        <p:spPr>
+          <a:xfrm>
+            <a:off x="4818888" y="3099816"/>
+            <a:ext cx="3986784" cy="274320"/>
+          </a:xfrm>
+          <a:prstGeom prst="rect">
+            <a:avLst/>
+          </a:prstGeom>
+          <a:noFill/>
+          <a:ln/>
+        </p:spPr>
+        <p:txBody>
+          <a:bodyPr wrap="square" lIns="0" tIns="0" rIns="0" bIns="0" rtlCol="0" anchor="ctr"/>
+          <a:lstStyle/>
+          <a:p>
+            <a:pPr marL="0" indent="0">
+              <a:buNone/>
+            </a:pPr>
+            <a:r>
+              <a:rPr lang="en-US" sz="1200" b="1" dirty="0">
+                <a:solidFill>
+                  <a:srgbClr val="FFFFFF"/>
+                </a:solidFill>
+                <a:latin typeface="Calibri" pitchFamily="34" charset="0"/>
+                <a:ea typeface="Calibri" pitchFamily="34" charset="-122"/>
+                <a:cs typeface="Calibri" pitchFamily="34" charset="-120"/>
+              </a:rPr>
+              <a:t> Computacional</a:t>
+            </a:r>
+            <a:endParaRPr lang="en-US" sz="1200" dirty="0"/>
+          </a:p>
+        </p:txBody>
+      </p:sp>
+      <p:pic>
+        <p:nvPicPr>
+          <p:cNvPr id="6" name="Picture 5">
+            <a:extLst>
+              <a:ext uri="{FF2B5EF4-FFF2-40B4-BE49-F238E27FC236}">
+                <a16:creationId xmlns:a16="http://schemas.microsoft.com/office/drawing/2014/main" id="{4ADF6712-C4C8-5446-27C3-C1F850DDCE49}"/>
+              </a:ext>
+            </a:extLst>
+          </p:cNvPr>
+          <p:cNvPicPr>
+            <a:picLocks noChangeAspect="1"/>
+          </p:cNvPicPr>
+          <p:nvPr/>
+        </p:nvPicPr>
+        <p:blipFill>
+          <a:blip r:embed="rId3"/>
+          <a:stretch>
+            <a:fillRect/>
+          </a:stretch>
+        </p:blipFill>
+        <p:spPr>
+          <a:xfrm>
+            <a:off x="495162" y="1171956"/>
+            <a:ext cx="3835718" cy="3119717"/>
+          </a:xfrm>
+          <a:prstGeom prst="rect">
+            <a:avLst/>
+          </a:prstGeom>
+        </p:spPr>
+      </p:pic>
+      <p:pic>
+        <p:nvPicPr>
+          <p:cNvPr id="9" name="Picture 8">
+            <a:extLst>
+              <a:ext uri="{FF2B5EF4-FFF2-40B4-BE49-F238E27FC236}">
+                <a16:creationId xmlns:a16="http://schemas.microsoft.com/office/drawing/2014/main" id="{975CEAAE-B6E2-3019-1C62-58AB77DDC078}"/>
+              </a:ext>
+            </a:extLst>
+          </p:cNvPr>
+          <p:cNvPicPr>
+            <a:picLocks noChangeAspect="1"/>
+          </p:cNvPicPr>
+          <p:nvPr/>
+        </p:nvPicPr>
+        <p:blipFill>
+          <a:blip r:embed="rId4"/>
+          <a:stretch>
+            <a:fillRect/>
+          </a:stretch>
+        </p:blipFill>
+        <p:spPr>
+          <a:xfrm>
+            <a:off x="4851773" y="1347216"/>
+            <a:ext cx="4051099" cy="2944457"/>
+          </a:xfrm>
+          <a:prstGeom prst="rect">
+            <a:avLst/>
+          </a:prstGeom>
+        </p:spPr>
+      </p:pic>
+    </p:spTree>
+    <p:extLst>
+      <p:ext uri="{BB962C8B-B14F-4D97-AF65-F5344CB8AC3E}">
+        <p14:creationId xmlns:p14="http://schemas.microsoft.com/office/powerpoint/2010/main" val="1328538185"/>
+      </p:ext>
+    </p:extLst>
+  </p:cSld>
+  <p:clrMapOvr>
+    <a:masterClrMapping/>
+  </p:clrMapOvr>
+  <mc:AlternateContent xmlns:mc="http://schemas.openxmlformats.org/markup-compatibility/2006">
+    <mc:Choice xmlns:p159="http://schemas.microsoft.com/office/powerpoint/2015/09/main" Requires="p159">
+      <p:transition xmlns:p14="http://schemas.microsoft.com/office/powerpoint/2010/main" spd="slow" p14:dur="2000">
+        <p159:morph option="byObject"/>
+      </p:transition>
+    </mc:Choice>
+    <mc:Fallback>
+      <p:transition spd="slow">
+        <p:fade/>
+      </p:transition>
+    </mc:Fallback>
+  </mc:AlternateContent>
+</p:sld>
+</file>
+
+<file path=ppt/slides/slide25.xml><?xml version="1.0" encoding="utf-8"?>
 <p:sld xmlns:a="http://schemas.openxmlformats.org/drawingml/2006/main" xmlns:r="http://schemas.openxmlformats.org/officeDocument/2006/relationships" xmlns:p="http://schemas.openxmlformats.org/presentationml/2006/main">
   <p:cSld>
     <p:spTree>
@@ -22442,257 +22897,18 @@
   <p:clrMapOvr>
     <a:masterClrMapping/>
   </p:clrMapOvr>
-</p:sld>
-</file>
-
-<file path=ppt/slides/slide25.xml><?xml version="1.0" encoding="utf-8"?>
-<p:sld xmlns:a="http://schemas.openxmlformats.org/drawingml/2006/main" xmlns:r="http://schemas.openxmlformats.org/officeDocument/2006/relationships" xmlns:p="http://schemas.openxmlformats.org/presentationml/2006/main">
-  <p:cSld>
-    <p:spTree>
-      <p:nvGrpSpPr>
-        <p:cNvPr id="1" name="">
-          <a:extLst>
-            <a:ext uri="{FF2B5EF4-FFF2-40B4-BE49-F238E27FC236}">
-              <a16:creationId xmlns:a16="http://schemas.microsoft.com/office/drawing/2014/main" id="{224FF6E5-DD65-A9C9-6345-97B189D901D3}"/>
-            </a:ext>
-          </a:extLst>
-        </p:cNvPr>
-        <p:cNvGrpSpPr/>
-        <p:nvPr/>
-      </p:nvGrpSpPr>
-      <p:grpSpPr>
-        <a:xfrm>
-          <a:off x="0" y="0"/>
-          <a:ext cx="0" cy="0"/>
-          <a:chOff x="0" y="0"/>
-          <a:chExt cx="0" cy="0"/>
-        </a:xfrm>
-      </p:grpSpPr>
-      <p:sp>
-        <p:nvSpPr>
-          <p:cNvPr id="2" name="Shape 0">
-            <a:extLst>
-              <a:ext uri="{FF2B5EF4-FFF2-40B4-BE49-F238E27FC236}">
-                <a16:creationId xmlns:a16="http://schemas.microsoft.com/office/drawing/2014/main" id="{A9B3D0C6-51D4-6FF5-AF37-776CD30E5568}"/>
-              </a:ext>
-            </a:extLst>
-          </p:cNvPr>
-          <p:cNvSpPr/>
-          <p:nvPr/>
-        </p:nvSpPr>
-        <p:spPr>
-          <a:xfrm>
-            <a:off x="0" y="-27432"/>
-            <a:ext cx="9144000" cy="868680"/>
-          </a:xfrm>
-          <a:prstGeom prst="rect">
-            <a:avLst/>
-          </a:prstGeom>
-          <a:solidFill>
-            <a:schemeClr val="accent2">
-              <a:lumMod val="75000"/>
-            </a:schemeClr>
-          </a:solidFill>
-          <a:ln w="12700">
-            <a:solidFill>
-              <a:srgbClr val="333333"/>
-            </a:solidFill>
-            <a:prstDash val="solid"/>
-          </a:ln>
-        </p:spPr>
-        <p:txBody>
-          <a:bodyPr/>
-          <a:lstStyle/>
-          <a:p>
-            <a:endParaRPr lang="pt-BR"/>
-          </a:p>
-        </p:txBody>
-      </p:sp>
-      <p:sp>
-        <p:nvSpPr>
-          <p:cNvPr id="3" name="Text 1">
-            <a:extLst>
-              <a:ext uri="{FF2B5EF4-FFF2-40B4-BE49-F238E27FC236}">
-                <a16:creationId xmlns:a16="http://schemas.microsoft.com/office/drawing/2014/main" id="{F4A3942D-CE89-EB04-A265-4ED2B11A16D7}"/>
-              </a:ext>
-            </a:extLst>
-          </p:cNvPr>
-          <p:cNvSpPr/>
-          <p:nvPr/>
-        </p:nvSpPr>
-        <p:spPr>
-          <a:xfrm>
-            <a:off x="411480" y="91440"/>
-            <a:ext cx="8229600" cy="685800"/>
-          </a:xfrm>
-          <a:prstGeom prst="rect">
-            <a:avLst/>
-          </a:prstGeom>
-          <a:noFill/>
-          <a:ln/>
-        </p:spPr>
-        <p:txBody>
-          <a:bodyPr wrap="square" lIns="0" tIns="0" rIns="0" bIns="0" rtlCol="0" anchor="ctr"/>
-          <a:lstStyle/>
-          <a:p>
-            <a:pPr marL="0" indent="0" algn="l">
-              <a:buNone/>
-            </a:pPr>
-            <a:r>
-              <a:rPr lang="en-US" sz="3000" b="1" dirty="0" err="1">
-                <a:solidFill>
-                  <a:srgbClr val="FFFFFF"/>
-                </a:solidFill>
-                <a:latin typeface="Arial Black" pitchFamily="34" charset="0"/>
-              </a:rPr>
-              <a:t>Distribuição</a:t>
-            </a:r>
-            <a:r>
-              <a:rPr lang="en-US" sz="3000" b="1" dirty="0">
-                <a:solidFill>
-                  <a:srgbClr val="FFFFFF"/>
-                </a:solidFill>
-                <a:latin typeface="Arial Black" pitchFamily="34" charset="0"/>
-              </a:rPr>
-              <a:t> de </a:t>
-            </a:r>
-            <a:r>
-              <a:rPr lang="en-US" sz="3000" b="1" dirty="0" err="1">
-                <a:solidFill>
-                  <a:srgbClr val="FFFFFF"/>
-                </a:solidFill>
-                <a:latin typeface="Arial Black" pitchFamily="34" charset="0"/>
-              </a:rPr>
-              <a:t>Emissões</a:t>
-            </a:r>
-            <a:r>
-              <a:rPr lang="en-US" sz="3000" b="1" dirty="0">
-                <a:solidFill>
-                  <a:srgbClr val="FFFFFF"/>
-                </a:solidFill>
-                <a:latin typeface="Arial Black" pitchFamily="34" charset="0"/>
-              </a:rPr>
-              <a:t> (N1)</a:t>
-            </a:r>
-            <a:endParaRPr lang="en-US" sz="3000" dirty="0"/>
-          </a:p>
-        </p:txBody>
-      </p:sp>
-      <p:sp>
-        <p:nvSpPr>
-          <p:cNvPr id="24" name="Text 22">
-            <a:extLst>
-              <a:ext uri="{FF2B5EF4-FFF2-40B4-BE49-F238E27FC236}">
-                <a16:creationId xmlns:a16="http://schemas.microsoft.com/office/drawing/2014/main" id="{7562FC1E-FF62-8B6E-0480-C50B44C1BA69}"/>
-              </a:ext>
-            </a:extLst>
-          </p:cNvPr>
-          <p:cNvSpPr/>
-          <p:nvPr/>
-        </p:nvSpPr>
-        <p:spPr>
-          <a:xfrm>
-            <a:off x="4818888" y="3099816"/>
-            <a:ext cx="3986784" cy="274320"/>
-          </a:xfrm>
-          <a:prstGeom prst="rect">
-            <a:avLst/>
-          </a:prstGeom>
-          <a:noFill/>
-          <a:ln/>
-        </p:spPr>
-        <p:txBody>
-          <a:bodyPr wrap="square" lIns="0" tIns="0" rIns="0" bIns="0" rtlCol="0" anchor="ctr"/>
-          <a:lstStyle/>
-          <a:p>
-            <a:pPr marL="0" indent="0">
-              <a:buNone/>
-            </a:pPr>
-            <a:r>
-              <a:rPr lang="en-US" sz="1200" b="1" dirty="0">
-                <a:solidFill>
-                  <a:srgbClr val="FFFFFF"/>
-                </a:solidFill>
-                <a:latin typeface="Calibri" pitchFamily="34" charset="0"/>
-                <a:ea typeface="Calibri" pitchFamily="34" charset="-122"/>
-                <a:cs typeface="Calibri" pitchFamily="34" charset="-120"/>
-              </a:rPr>
-              <a:t> Computacional</a:t>
-            </a:r>
-            <a:endParaRPr lang="en-US" sz="1200" dirty="0"/>
-          </a:p>
-        </p:txBody>
-      </p:sp>
-      <p:pic>
-        <p:nvPicPr>
-          <p:cNvPr id="6" name="Picture 5">
-            <a:extLst>
-              <a:ext uri="{FF2B5EF4-FFF2-40B4-BE49-F238E27FC236}">
-                <a16:creationId xmlns:a16="http://schemas.microsoft.com/office/drawing/2014/main" id="{4ADF6712-C4C8-5446-27C3-C1F850DDCE49}"/>
-              </a:ext>
-            </a:extLst>
-          </p:cNvPr>
-          <p:cNvPicPr>
-            <a:picLocks noChangeAspect="1"/>
-          </p:cNvPicPr>
-          <p:nvPr/>
-        </p:nvPicPr>
-        <p:blipFill>
-          <a:blip r:embed="rId3"/>
-          <a:stretch>
-            <a:fillRect/>
-          </a:stretch>
-        </p:blipFill>
-        <p:spPr>
-          <a:xfrm>
-            <a:off x="495162" y="1171956"/>
-            <a:ext cx="3835718" cy="3119717"/>
-          </a:xfrm>
-          <a:prstGeom prst="rect">
-            <a:avLst/>
-          </a:prstGeom>
-        </p:spPr>
-      </p:pic>
-      <p:pic>
-        <p:nvPicPr>
-          <p:cNvPr id="9" name="Picture 8">
-            <a:extLst>
-              <a:ext uri="{FF2B5EF4-FFF2-40B4-BE49-F238E27FC236}">
-                <a16:creationId xmlns:a16="http://schemas.microsoft.com/office/drawing/2014/main" id="{975CEAAE-B6E2-3019-1C62-58AB77DDC078}"/>
-              </a:ext>
-            </a:extLst>
-          </p:cNvPr>
-          <p:cNvPicPr>
-            <a:picLocks noChangeAspect="1"/>
-          </p:cNvPicPr>
-          <p:nvPr/>
-        </p:nvPicPr>
-        <p:blipFill>
-          <a:blip r:embed="rId4"/>
-          <a:stretch>
-            <a:fillRect/>
-          </a:stretch>
-        </p:blipFill>
-        <p:spPr>
-          <a:xfrm>
-            <a:off x="4851773" y="1347216"/>
-            <a:ext cx="4051099" cy="2944457"/>
-          </a:xfrm>
-          <a:prstGeom prst="rect">
-            <a:avLst/>
-          </a:prstGeom>
-        </p:spPr>
-      </p:pic>
-    </p:spTree>
-    <p:extLst>
-      <p:ext uri="{BB962C8B-B14F-4D97-AF65-F5344CB8AC3E}">
-        <p14:creationId xmlns:p14="http://schemas.microsoft.com/office/powerpoint/2010/main" val="1328538185"/>
-      </p:ext>
-    </p:extLst>
-  </p:cSld>
-  <p:clrMapOvr>
-    <a:masterClrMapping/>
-  </p:clrMapOvr>
+  <mc:AlternateContent xmlns:mc="http://schemas.openxmlformats.org/markup-compatibility/2006">
+    <mc:Choice xmlns:p159="http://schemas.microsoft.com/office/powerpoint/2015/09/main" Requires="p159">
+      <p:transition xmlns:p14="http://schemas.microsoft.com/office/powerpoint/2010/main" spd="slow" p14:dur="2000">
+        <p159:morph option="byObject"/>
+      </p:transition>
+    </mc:Choice>
+    <mc:Fallback>
+      <p:transition spd="slow">
+        <p:fade/>
+      </p:transition>
+    </mc:Fallback>
+  </mc:AlternateContent>
 </p:sld>
 </file>
 
@@ -22960,6 +23176,18 @@
   <p:clrMapOvr>
     <a:masterClrMapping/>
   </p:clrMapOvr>
+  <mc:AlternateContent xmlns:mc="http://schemas.openxmlformats.org/markup-compatibility/2006">
+    <mc:Choice xmlns:p159="http://schemas.microsoft.com/office/powerpoint/2015/09/main" Requires="p159">
+      <p:transition xmlns:p14="http://schemas.microsoft.com/office/powerpoint/2010/main" spd="slow" p14:dur="2000">
+        <p159:morph option="byObject"/>
+      </p:transition>
+    </mc:Choice>
+    <mc:Fallback>
+      <p:transition spd="slow">
+        <p:fade/>
+      </p:transition>
+    </mc:Fallback>
+  </mc:AlternateContent>
 </p:sld>
 </file>
 
@@ -23194,6 +23422,18 @@
   <p:clrMapOvr>
     <a:masterClrMapping/>
   </p:clrMapOvr>
+  <mc:AlternateContent xmlns:mc="http://schemas.openxmlformats.org/markup-compatibility/2006">
+    <mc:Choice xmlns:p159="http://schemas.microsoft.com/office/powerpoint/2015/09/main" Requires="p159">
+      <p:transition xmlns:p14="http://schemas.microsoft.com/office/powerpoint/2010/main" spd="slow" p14:dur="2000">
+        <p159:morph option="byObject"/>
+      </p:transition>
+    </mc:Choice>
+    <mc:Fallback>
+      <p:transition spd="slow">
+        <p:fade/>
+      </p:transition>
+    </mc:Fallback>
+  </mc:AlternateContent>
 </p:sld>
 </file>
 
@@ -24374,6 +24614,18 @@
   <p:clrMapOvr>
     <a:masterClrMapping/>
   </p:clrMapOvr>
+  <mc:AlternateContent xmlns:mc="http://schemas.openxmlformats.org/markup-compatibility/2006">
+    <mc:Choice xmlns:p159="http://schemas.microsoft.com/office/powerpoint/2015/09/main" Requires="p159">
+      <p:transition xmlns:p14="http://schemas.microsoft.com/office/powerpoint/2010/main" spd="slow" p14:dur="2000">
+        <p159:morph option="byObject"/>
+      </p:transition>
+    </mc:Choice>
+    <mc:Fallback>
+      <p:transition spd="slow">
+        <p:fade/>
+      </p:transition>
+    </mc:Fallback>
+  </mc:AlternateContent>
 </p:sld>
 </file>
 
@@ -25716,6 +25968,18 @@
   <p:clrMapOvr>
     <a:masterClrMapping/>
   </p:clrMapOvr>
+  <mc:AlternateContent xmlns:mc="http://schemas.openxmlformats.org/markup-compatibility/2006">
+    <mc:Choice xmlns:p159="http://schemas.microsoft.com/office/powerpoint/2015/09/main" Requires="p159">
+      <p:transition xmlns:p14="http://schemas.microsoft.com/office/powerpoint/2010/main" spd="slow" p14:dur="2000">
+        <p159:morph option="byObject"/>
+      </p:transition>
+    </mc:Choice>
+    <mc:Fallback>
+      <p:transition spd="slow">
+        <p:fade/>
+      </p:transition>
+    </mc:Fallback>
+  </mc:AlternateContent>
 </p:sld>
 </file>
 
@@ -26627,6 +26891,18 @@
   <p:clrMapOvr>
     <a:masterClrMapping/>
   </p:clrMapOvr>
+  <mc:AlternateContent xmlns:mc="http://schemas.openxmlformats.org/markup-compatibility/2006">
+    <mc:Choice xmlns:p159="http://schemas.microsoft.com/office/powerpoint/2015/09/main" Requires="p159">
+      <p:transition xmlns:p14="http://schemas.microsoft.com/office/powerpoint/2010/main" spd="slow" p14:dur="2000">
+        <p159:morph option="byObject"/>
+      </p:transition>
+    </mc:Choice>
+    <mc:Fallback>
+      <p:transition spd="slow">
+        <p:fade/>
+      </p:transition>
+    </mc:Fallback>
+  </mc:AlternateContent>
 </p:sld>
 </file>
 
@@ -27344,6 +27620,18 @@
   <p:clrMapOvr>
     <a:masterClrMapping/>
   </p:clrMapOvr>
+  <mc:AlternateContent xmlns:mc="http://schemas.openxmlformats.org/markup-compatibility/2006">
+    <mc:Choice xmlns:p159="http://schemas.microsoft.com/office/powerpoint/2015/09/main" Requires="p159">
+      <p:transition xmlns:p14="http://schemas.microsoft.com/office/powerpoint/2010/main" spd="slow" p14:dur="2000">
+        <p159:morph option="byObject"/>
+      </p:transition>
+    </mc:Choice>
+    <mc:Fallback>
+      <p:transition spd="slow">
+        <p:fade/>
+      </p:transition>
+    </mc:Fallback>
+  </mc:AlternateContent>
 </p:sld>
 </file>
 
@@ -28782,6 +29070,18 @@
   <p:clrMapOvr>
     <a:masterClrMapping/>
   </p:clrMapOvr>
+  <mc:AlternateContent xmlns:mc="http://schemas.openxmlformats.org/markup-compatibility/2006">
+    <mc:Choice xmlns:p159="http://schemas.microsoft.com/office/powerpoint/2015/09/main" Requires="p159">
+      <p:transition xmlns:p14="http://schemas.microsoft.com/office/powerpoint/2010/main" spd="slow" p14:dur="2000">
+        <p159:morph option="byObject"/>
+      </p:transition>
+    </mc:Choice>
+    <mc:Fallback>
+      <p:transition spd="slow">
+        <p:fade/>
+      </p:transition>
+    </mc:Fallback>
+  </mc:AlternateContent>
 </p:sld>
 </file>
 
@@ -28931,6 +29231,18 @@
   <p:clrMapOvr>
     <a:masterClrMapping/>
   </p:clrMapOvr>
+  <mc:AlternateContent xmlns:mc="http://schemas.openxmlformats.org/markup-compatibility/2006">
+    <mc:Choice xmlns:p159="http://schemas.microsoft.com/office/powerpoint/2015/09/main" Requires="p159">
+      <p:transition xmlns:p14="http://schemas.microsoft.com/office/powerpoint/2010/main" spd="slow" p14:dur="2000">
+        <p159:morph option="byObject"/>
+      </p:transition>
+    </mc:Choice>
+    <mc:Fallback>
+      <p:transition spd="slow">
+        <p:fade/>
+      </p:transition>
+    </mc:Fallback>
+  </mc:AlternateContent>
 </p:sld>
 </file>
 
@@ -29080,6 +29392,18 @@
   <p:clrMapOvr>
     <a:masterClrMapping/>
   </p:clrMapOvr>
+  <mc:AlternateContent xmlns:mc="http://schemas.openxmlformats.org/markup-compatibility/2006">
+    <mc:Choice xmlns:p159="http://schemas.microsoft.com/office/powerpoint/2015/09/main" Requires="p159">
+      <p:transition xmlns:p14="http://schemas.microsoft.com/office/powerpoint/2010/main" spd="slow" p14:dur="2000">
+        <p159:morph option="byObject"/>
+      </p:transition>
+    </mc:Choice>
+    <mc:Fallback>
+      <p:transition spd="slow">
+        <p:fade/>
+      </p:transition>
+    </mc:Fallback>
+  </mc:AlternateContent>
 </p:sld>
 </file>
 
@@ -29441,6 +29765,18 @@
   <p:clrMapOvr>
     <a:masterClrMapping/>
   </p:clrMapOvr>
+  <mc:AlternateContent xmlns:mc="http://schemas.openxmlformats.org/markup-compatibility/2006">
+    <mc:Choice xmlns:p159="http://schemas.microsoft.com/office/powerpoint/2015/09/main" Requires="p159">
+      <p:transition xmlns:p14="http://schemas.microsoft.com/office/powerpoint/2010/main" spd="slow" p14:dur="2000">
+        <p159:morph option="byObject"/>
+      </p:transition>
+    </mc:Choice>
+    <mc:Fallback>
+      <p:transition spd="slow">
+        <p:fade/>
+      </p:transition>
+    </mc:Fallback>
+  </mc:AlternateContent>
 </p:sld>
 </file>
 
@@ -31967,6 +32303,18 @@
   <p:clrMapOvr>
     <a:masterClrMapping/>
   </p:clrMapOvr>
+  <mc:AlternateContent xmlns:mc="http://schemas.openxmlformats.org/markup-compatibility/2006">
+    <mc:Choice xmlns:p159="http://schemas.microsoft.com/office/powerpoint/2015/09/main" Requires="p159">
+      <p:transition xmlns:p14="http://schemas.microsoft.com/office/powerpoint/2010/main" spd="slow" p14:dur="2000">
+        <p159:morph option="byObject"/>
+      </p:transition>
+    </mc:Choice>
+    <mc:Fallback>
+      <p:transition spd="slow">
+        <p:fade/>
+      </p:transition>
+    </mc:Fallback>
+  </mc:AlternateContent>
 </p:sld>
 </file>
 
@@ -32690,6 +33038,18 @@
   <p:clrMapOvr>
     <a:masterClrMapping/>
   </p:clrMapOvr>
+  <mc:AlternateContent xmlns:mc="http://schemas.openxmlformats.org/markup-compatibility/2006">
+    <mc:Choice xmlns:p159="http://schemas.microsoft.com/office/powerpoint/2015/09/main" Requires="p159">
+      <p:transition xmlns:p14="http://schemas.microsoft.com/office/powerpoint/2010/main" spd="slow" p14:dur="2000">
+        <p159:morph option="byObject"/>
+      </p:transition>
+    </mc:Choice>
+    <mc:Fallback>
+      <p:transition spd="slow">
+        <p:fade/>
+      </p:transition>
+    </mc:Fallback>
+  </mc:AlternateContent>
 </p:sld>
 </file>
 

</xml_diff>